<commit_message>
Deck: three ways in, semantic routing visual, consistent slide structure
Q2b shows how stakeholders use the layer: BI dashboards, the AI assistant,
and data plus ML results pushed into the CRM. Q2a swaps the used-by row for
a governance strip. Q5 shows the semantic layer routing a question to the
model with the right grain. Every question slide now has the same shape:
title, one-line lead, visual, takeaway banner.

Co-Authored-By: Claude Opus 5.5 <noreply@anthropic.com>
</commit_message>
<xml_diff>
--- a/demos/calgary-transit/web/public/downloads/data-product-case-study.pptx
+++ b/demos/calgary-transit/web/public/downloads/data-product-case-study.pptx
@@ -1139,7 +1139,8 @@
           <a:p>
             <a:r>
               <a:rPr lang="en-US" dirty="0"/>
-              <a:t>• The technical heart: 'An AI that guesses the grain double counts. One grain per model means it can't.'
+              <a:t>• Three ways in, one source of truth. Most people never open a new tool: the data comes to the CRM.
+• The technical point on AI: 'An AI that guesses the grain double counts. One grain per model means it can't.'
 • Shipped first as an internal Customer Success bot; I led discovery for the client-facing version.
 • The example question is illustrative. [Your story: a real question the bot answered.]</a:t>
             </a:r>
@@ -1496,7 +1497,8 @@
           <a:p>
             <a:r>
               <a:rPr lang="en-US" dirty="0"/>
-              <a:t>• Slow down. This is the line to remember.
+              <a:t>• Trace the route once: 'An AI that guesses the grain double counts. The semantic layer sends each question to the model with the right grain, so it matches BI.'
+• Then land the banner slowly. It's the line to remember.
 • [Your story: the first time a team trusted an answer without double-checking it.]</a:t>
             </a:r>
             <a:endParaRPr lang="en-US" dirty="0"/>

</xml_diff>

<commit_message>
Deck: value slide (fresh, consistent, observable, self-serve), stack in Q3, demo hand-off on the close
Value cards show 4x-a-day refreshes, one number everywhere, monitored
pipelines and self-serve, each against the old state; the 30-minute stat is
gone. Q3b lists what each tool did: built in dbt, stored in Snowflake,
orchestrated by Airflow on AWS, versioned in GitHub, documented in dbt docs
and Confluence. The demo slide and its screenshots are removed; the thank-you
slide hands off to the live demo and carries the demo script in its notes.

Co-Authored-By: Claude Opus 5.5 <noreply@anthropic.com>
</commit_message>
<xml_diff>
--- a/demos/calgary-transit/web/public/downloads/data-product-case-study.pptx
+++ b/demos/calgary-transit/web/public/downloads/data-product-case-study.pptx
@@ -16,10 +16,9 @@
     <p:sldId id="264" r:id="rId10"/>
     <p:sldId id="265" r:id="rId11"/>
     <p:sldId id="266" r:id="rId12"/>
-    <p:sldId id="267" r:id="rId13"/>
   </p:sldIdLst>
   <p:notesMasterIdLst>
-    <p:notesMasterId r:id="rId14"/>
+    <p:notesMasterId r:id="rId13"/>
   </p:notesMasterIdLst>
   <p:sldSz cx="9144000" cy="5143500"/>
   <p:notesSz cx="5143500" cy="9144000"/>
@@ -601,8 +600,7 @@
           <a:p>
             <a:r>
               <a:rPr lang="en-US" dirty="0"/>
-              <a:t>• [Your story: swap in whatever you'd genuinely do differently.]
-• Transition: 'I can't show you StellarAlgo's data, so I rebuilt the same approach on the City's open data.'</a:t>
+              <a:t>• [Your story: swap in whatever you'd genuinely do differently.]</a:t>
             </a:r>
             <a:endParaRPr lang="en-US" dirty="0"/>
           </a:p>
@@ -690,12 +688,13 @@
           <a:p>
             <a:r>
               <a:rPr lang="en-US" dirty="0"/>
-              <a:t>• LIVE (5 min). Open the site before the interview. If the internet fails, these screenshots carry it.
+              <a:t>• Read the line on the slide, then switch to the browser.
+• LIVE DEMO (5 min). Have codychandler.ca/data-demos/calgary-transit open in a tab. Backup if the internet fails: the local copy (npm run dev).
 • 1 · Approach page, lineage graph: 'Same layers as StellarAlgo: three City datasets, tested in dbt, run daily by Airflow.' (45 s)
 • 2 · Dashboard: read the ⓘ headline. Then the 311 chart: 'My first cut said complaints per trip were up 43%. Lost Property moved into 311 in 2021. I fixed it once, in the data, so every consumer gets it right. Like for like it's 12%.' (1.25 min)
 • 3 · Predict: Advertising and Communications (usually low), then Transit Pass Programs (usually high). 'Tested on 2025, a year it never saw, it catches more slow requests than the rule of thumb.' (1 min)
 • 4 · Ask: 'How has ridership recovered since the pandemic?' While it works: 'it writes SQL against the same gold tables.' Read the answer, glance at the chart, open 'Show how this was answered'. Payoff: 'Same number as the dashboard. One source of truth.' (1.5 min)
-• Close: 'That's the work I'd bring to the City.' Then the last slide.</a:t>
+• Close: 'That's the work I'd bring to the City.' Then: 'Happy to take questions.'</a:t>
             </a:r>
             <a:endParaRPr lang="en-US" dirty="0"/>
           </a:p>
@@ -719,94 +718,6 @@
             <a:fld id="{F7021451-1387-4CA6-816F-3879F97B5CBC}" type="slidenum">
               <a:rPr lang="en-US"/>
               <a:t>11</a:t>
-            </a:fld>
-            <a:endParaRPr lang="en-US"/>
-          </a:p>
-        </p:txBody>
-      </p:sp>
-    </p:spTree>
-    <p:extLst>
-      <p:ext uri="{BB962C8B-B14F-4D97-AF65-F5344CB8AC3E}">
-        <p14:creationId xmlns:p14="http://schemas.microsoft.com/office/powerpoint/2010/main" val="1024086991"/>
-      </p:ext>
-    </p:extLst>
-  </p:cSld>
-  <p:clrMapOvr>
-    <a:masterClrMapping/>
-  </p:clrMapOvr>
-</p:notes>
-</file>
-
-<file path=ppt/notesSlides/notesSlide12.xml><?xml version="1.0" encoding="utf-8"?>
-<p:notes xmlns:a="http://schemas.openxmlformats.org/drawingml/2006/main" xmlns:r="http://schemas.openxmlformats.org/officeDocument/2006/relationships" xmlns:p="http://schemas.openxmlformats.org/presentationml/2006/main">
-  <p:cSld>
-    <p:spTree>
-      <p:nvGrpSpPr>
-        <p:cNvPr id="1" name=""/>
-        <p:cNvGrpSpPr/>
-        <p:nvPr/>
-      </p:nvGrpSpPr>
-      <p:grpSpPr>
-        <a:xfrm>
-          <a:off x="0" y="0"/>
-          <a:ext cx="0" cy="0"/>
-          <a:chOff x="0" y="0"/>
-          <a:chExt cx="0" cy="0"/>
-        </a:xfrm>
-      </p:grpSpPr>
-      <p:sp>
-        <p:nvSpPr>
-          <p:cNvPr id="2" name="Slide Image Placeholder 1"/>
-          <p:cNvSpPr>
-            <a:spLocks noGrp="1" noRot="1" noChangeAspect="1"/>
-          </p:cNvSpPr>
-          <p:nvPr>
-            <p:ph type="sldImg"/>
-          </p:nvPr>
-        </p:nvSpPr>
-        <p:spPr/>
-      </p:sp>
-      <p:sp>
-        <p:nvSpPr>
-          <p:cNvPr id="3" name="Notes Placeholder 2"/>
-          <p:cNvSpPr>
-            <a:spLocks noGrp="1"/>
-          </p:cNvSpPr>
-          <p:nvPr>
-            <p:ph type="body" idx="1"/>
-          </p:nvPr>
-        </p:nvSpPr>
-        <p:spPr/>
-        <p:txBody>
-          <a:bodyPr/>
-          <a:lstStyle/>
-          <a:p>
-            <a:r>
-              <a:rPr lang="en-US" dirty="0"/>
-              <a:t>• Stop talking. Leave this up for questions.</a:t>
-            </a:r>
-            <a:endParaRPr lang="en-US" dirty="0"/>
-          </a:p>
-        </p:txBody>
-      </p:sp>
-      <p:sp>
-        <p:nvSpPr>
-          <p:cNvPr id="4" name="Slide Number Placeholder 3"/>
-          <p:cNvSpPr>
-            <a:spLocks noGrp="1"/>
-          </p:cNvSpPr>
-          <p:nvPr>
-            <p:ph type="sldNum" sz="quarter" idx="10"/>
-          </p:nvPr>
-        </p:nvSpPr>
-        <p:spPr/>
-        <p:txBody>
-          <a:bodyPr/>
-          <a:lstStyle/>
-          <a:p>
-            <a:fld id="{F7021451-1387-4CA6-816F-3879F97B5CBC}" type="slidenum">
-              <a:rPr lang="en-US"/>
-              <a:t>12</a:t>
             </a:fld>
             <a:endParaRPr lang="en-US"/>
           </a:p>
@@ -1230,7 +1141,8 @@
           <a:p>
             <a:r>
               <a:rPr lang="en-US" dirty="0"/>
-              <a:t>• Ten seconds per number. The banner is the answer to question 1.
+              <a:t>• Ten seconds per card. The banner is the answer to question 1.
+• Observable: freshness checked against each domain's target, dbt tests on every run, AI-written digests of pipeline errors, and cost tracked per model.
 • [Your story: an adoption or time-saved number.]</a:t>
             </a:r>
             <a:endParaRPr lang="en-US" dirty="0"/>
@@ -1320,6 +1232,7 @@
             <a:r>
               <a:rPr lang="en-US" dirty="0"/>
               <a:t>• One breath across the strip. The why matters more than the stack.
+• On b, say it plainly: 'Modelled in dbt, stored in Snowflake, orchestrated in Airflow, every change versioned in GitHub and documented in dbt docs and Confluence.'
 • [Your story: how you ran requirements, and the real build order.]</a:t>
             </a:r>
             <a:endParaRPr lang="en-US" dirty="0"/>
@@ -1966,55 +1879,6 @@
       <p:pic>
         <p:nvPicPr>
           <p:cNvPr id="2" name="Image 0" descr="Slide 11">    </p:cNvPr>
-          <p:cNvPicPr>
-            <a:picLocks noChangeAspect="1"/>
-          </p:cNvPicPr>
-          <p:nvPr/>
-        </p:nvPicPr>
-        <p:blipFill>
-          <a:blip r:embed="rId1"/>
-          <a:stretch>
-            <a:fillRect/>
-          </a:stretch>
-        </p:blipFill>
-        <p:spPr>
-          <a:xfrm>
-            <a:off x="0" y="0"/>
-            <a:ext cx="9144000" cy="5143500"/>
-          </a:xfrm>
-          <a:prstGeom prst="rect">
-            <a:avLst/>
-          </a:prstGeom>
-        </p:spPr>
-      </p:pic>
-    </p:spTree>
-  </p:cSld>
-  <p:clrMapOvr>
-    <a:masterClrMapping/>
-  </p:clrMapOvr>
-</p:sld>
-</file>
-
-<file path=ppt/slides/slide12.xml><?xml version="1.0" encoding="utf-8"?>
-<p:sld xmlns:a="http://schemas.openxmlformats.org/drawingml/2006/main" xmlns:r="http://schemas.openxmlformats.org/officeDocument/2006/relationships" xmlns:p="http://schemas.openxmlformats.org/presentationml/2006/main">
-  <p:cSld name="Slide 12">
-    <p:spTree>
-      <p:nvGrpSpPr>
-        <p:cNvPr id="1" name=""/>
-        <p:cNvGrpSpPr/>
-        <p:nvPr/>
-      </p:nvGrpSpPr>
-      <p:grpSpPr>
-        <a:xfrm>
-          <a:off x="0" y="0"/>
-          <a:ext cx="0" cy="0"/>
-          <a:chOff x="0" y="0"/>
-          <a:chExt cx="0" cy="0"/>
-        </a:xfrm>
-      </p:grpSpPr>
-      <p:pic>
-        <p:nvPicPr>
-          <p:cNvPr id="2" name="Image 0" descr="Slide 12">    </p:cNvPr>
           <p:cNvPicPr>
             <a:picLocks noChangeAspect="1"/>
           </p:cNvPicPr>

</xml_diff>

<commit_message>
Deck review: consistent titles, example question and notes
Q4's title matches the agenda. One example question across Q2b and Q5. The
corner label is dropped on the dark title and closing slides. Speaker notes
updated for the current wording.

Co-Authored-By: Claude Opus 5.5 <noreply@anthropic.com>
</commit_message>
<xml_diff>
--- a/demos/calgary-transit/web/public/downloads/data-product-case-study.pptx
+++ b/demos/calgary-transit/web/public/downloads/data-product-case-study.pptx
@@ -600,7 +600,8 @@
           <a:p>
             <a:r>
               <a:rPr lang="en-US" dirty="0"/>
-              <a:t>• [Your story: swap in whatever you'd genuinely do differently.]</a:t>
+              <a:t>• [Your story: swap in whatever you'd genuinely do differently.]
+• Land the City line slowly. It's the bridge to the role, and the lead-in to the demo.</a:t>
             </a:r>
             <a:endParaRPr lang="en-US" dirty="0"/>
           </a:p>
@@ -1050,7 +1051,7 @@
           <a:p>
             <a:r>
               <a:rPr lang="en-US" dirty="0"/>
-              <a:t>• Three ways in, one source of truth. Most people never open a new tool: the data comes to the CRM.
+              <a:t>• Three ways to use the same tables. Most people never open a new tool: the data comes to them in the CRM.
 • The technical point on AI: 'An AI that guesses the grain double counts. One grain per model means it can't.'
 • Shipped first as an internal Customer Success bot; I led discovery for the client-facing version.
 • The example question is illustrative. [Your story: a real question the bot answered.]</a:t>

</xml_diff>

<commit_message>
Deck: remove speaker notes and the presenter view
Drops the Notes panel, the synced presenter window and every slide's notes,
and stops writing notes into the PowerPoint export.

Co-Authored-By: Claude Opus 5.5 <noreply@anthropic.com>
</commit_message>
<xml_diff>
--- a/demos/calgary-transit/web/public/downloads/data-product-case-study.pptx
+++ b/demos/calgary-transit/web/public/downloads/data-product-case-study.pptx
@@ -512,7 +512,7 @@
           <a:p>
             <a:r>
               <a:rPr lang="en-US" dirty="0"/>
-              <a:t>• [Your story: one line on who you are.] Then: 'I'll answer your six questions in order, then show it live.'</a:t>
+              <a:t/>
             </a:r>
             <a:endParaRPr lang="en-US" dirty="0"/>
           </a:p>
@@ -600,8 +600,7 @@
           <a:p>
             <a:r>
               <a:rPr lang="en-US" dirty="0"/>
-              <a:t>• [Your story: swap in whatever you'd genuinely do differently.]
-• Then go straight to the thank-you slide and the demo.</a:t>
+              <a:t/>
             </a:r>
             <a:endParaRPr lang="en-US" dirty="0"/>
           </a:p>
@@ -689,13 +688,7 @@
           <a:p>
             <a:r>
               <a:rPr lang="en-US" dirty="0"/>
-              <a:t>• Read the line on the slide, then switch to the browser.
-• LIVE DEMO (5 min). Have codychandler.ca/data-demos/calgary-transit open in a tab. Backup if the internet fails: the local copy (npm run dev).
-• 1 · Approach page, lineage graph: 'Same layers as StellarAlgo: three City datasets, tested in dbt, run daily by Airflow.' (45 s)
-• 2 · Dashboard: read the ⓘ headline. Then the 311 chart: 'My first cut said complaints per trip were up 43%. Lost Property moved into 311 in 2021. I fixed it once, in the data, so every consumer gets it right. Like for like it's 12%.' (1.25 min)
-• 3 · Predict: Advertising and Communications (usually low), then Transit Pass Programs (usually high). 'Tested on 2025, a year it never saw, it catches more slow requests than the rule of thumb.' (1 min)
-• 4 · Ask: 'How has ridership recovered since the pandemic?' While it works: 'it writes SQL against the same gold tables.' Read the answer, glance at the chart, open 'Show how this was answered'. Payoff: 'Same number as the dashboard. One source of truth.' (1.5 min)
-• Close: 'That's the work I'd bring to the City.' Then: 'Happy to take questions.'</a:t>
+              <a:t/>
             </a:r>
             <a:endParaRPr lang="en-US" dirty="0"/>
           </a:p>
@@ -783,8 +776,7 @@
           <a:p>
             <a:r>
               <a:rPr lang="en-US" dirty="0"/>
-              <a:t>• Fifteen seconds. Every slide title is one of their questions.
-• Say: 'Then five minutes live, on City of Calgary open data.'</a:t>
+              <a:t/>
             </a:r>
             <a:endParaRPr lang="en-US" dirty="0"/>
           </a:p>
@@ -872,9 +864,7 @@
           <a:p>
             <a:r>
               <a:rPr lang="en-US" dirty="0"/>
-              <a:t>• Keep it to the business pain, not the tech.
-• My role: Director, Product Innovation &amp; Analytics. I owned the product from planning to general availability.
-• [Your story: one concrete moment when inconsistent numbers hurt.]</a:t>
+              <a:t/>
             </a:r>
             <a:endParaRPr lang="en-US" dirty="0"/>
           </a:p>
@@ -962,8 +952,7 @@
           <a:p>
             <a:r>
               <a:rPr lang="en-US" dirty="0"/>
-              <a:t>• Left to right, once: product analytics, customer data (ticketing, acquisition) and client config, with every metric defined once in dbt, feeding every consumer.
-• Governance is built in: personal data masked on landing, access by role, and a data contract.</a:t>
+              <a:t/>
             </a:r>
             <a:endParaRPr lang="en-US" dirty="0"/>
           </a:p>
@@ -1051,10 +1040,7 @@
           <a:p>
             <a:r>
               <a:rPr lang="en-US" dirty="0"/>
-              <a:t>• Three ways to use the same tables. Most people never open a new tool: the data comes to them in the CRM.
-• The technical point on AI: 'An AI that guesses the grain double counts. One grain per model means it can't.'
-• Shipped first as an internal Customer Success bot; I led discovery for the client-facing version.
-• The example question is illustrative. [Your story: a real question the bot answered.]</a:t>
+              <a:t/>
             </a:r>
             <a:endParaRPr lang="en-US" dirty="0"/>
           </a:p>
@@ -1142,9 +1128,7 @@
           <a:p>
             <a:r>
               <a:rPr lang="en-US" dirty="0"/>
-              <a:t>• Ten seconds per card. The banner is the answer to question 1.
-• Observable: freshness checked against each domain's target, dbt tests on every run, AI-written digests of pipeline errors, and cost tracked per model.
-• [Your story: an adoption or time-saved number.]</a:t>
+              <a:t/>
             </a:r>
             <a:endParaRPr lang="en-US" dirty="0"/>
           </a:p>
@@ -1232,9 +1216,7 @@
           <a:p>
             <a:r>
               <a:rPr lang="en-US" dirty="0"/>
-              <a:t>• One breath across the strip. The why matters more than the stack.
-• On b, say it plainly: 'Modelled in dbt, stored in Snowflake, orchestrated in Airflow, every change versioned in GitHub and documented in dbt docs and Confluence.'
-• [Your story: how you ran requirements, and the real build order.]</a:t>
+              <a:t/>
             </a:r>
             <a:endParaRPr lang="en-US" dirty="0"/>
           </a:p>
@@ -1322,8 +1304,7 @@
           <a:p>
             <a:r>
               <a:rPr lang="en-US" dirty="0"/>
-              <a:t>• Spend most of the time on the People row. It's the one the City will relate to.
-• [Your story: the conversation that got the data contract agreed. Who pushed back, and what changed their mind?]</a:t>
+              <a:t/>
             </a:r>
             <a:endParaRPr lang="en-US" dirty="0"/>
           </a:p>
@@ -1411,9 +1392,7 @@
           <a:p>
             <a:r>
               <a:rPr lang="en-US" dirty="0"/>
-              <a:t>• Trace the route once: 'An AI that guesses the grain double counts. The semantic layer sends each question to the model with the right grain, so it matches BI.'
-• Then land the banner slowly. It's the line to remember.
-• [Your story: the first time a team trusted an answer without double-checking it.]</a:t>
+              <a:t/>
             </a:r>
             <a:endParaRPr lang="en-US" dirty="0"/>
           </a:p>

</xml_diff>